<commit_message>
data_min_timestamp_fetching is done from db now
</commit_message>
<xml_diff>
--- a/docs/CryptoSight_Presentation.pptx
+++ b/docs/CryptoSight_Presentation.pptx
@@ -1474,6 +1474,926 @@
           </a:p>
         </p:txBody>
       </p:sp>
+      <p:sp>
+        <p:nvSpPr>
+          <p:cNvPr id="100" name="ChartCard"/>
+          <p:cNvSpPr/>
+          <p:nvPr/>
+        </p:nvSpPr>
+        <p:spPr>
+          <a:xfrm>
+            <a:off x="7150000" y="1450000"/>
+            <a:ext cx="4650000" cy="3800000"/>
+          </a:xfrm>
+          <a:prstGeom prst="roundRect">
+            <a:avLst>
+              <a:gd name="adj" fmla="val 4500"/>
+            </a:avLst>
+          </a:prstGeom>
+          <a:solidFill>
+            <a:srgbClr val="FFFFFF">
+              <a:alpha val="7000"/>
+            </a:srgbClr>
+          </a:solidFill>
+          <a:ln w="9525">
+            <a:solidFill>
+              <a:srgbClr val="FFFFFF">
+                <a:alpha val="18000"/>
+              </a:srgbClr>
+            </a:solidFill>
+          </a:ln>
+        </p:spPr>
+        <p:txBody>
+          <a:bodyPr/>
+          <a:lstStyle/>
+          <a:p>
+            <a:endParaRPr lang="en-US"/>
+          </a:p>
+        </p:txBody>
+      </p:sp>
+      <p:sp>
+        <p:nvSpPr>
+          <p:cNvPr id="101" name="Ticker"/>
+          <p:cNvSpPr/>
+          <p:nvPr/>
+        </p:nvSpPr>
+        <p:spPr>
+          <a:xfrm>
+            <a:off x="7430000" y="1680000"/>
+            <a:ext cx="2400000" cy="240000"/>
+          </a:xfrm>
+          <a:prstGeom prst="rect">
+            <a:avLst/>
+          </a:prstGeom>
+          <a:noFill/>
+          <a:ln/>
+        </p:spPr>
+        <p:txBody>
+          <a:bodyPr wrap="square" lIns="0" tIns="0" rIns="0" bIns="0" anchor="ctr"/>
+          <a:lstStyle/>
+          <a:p>
+            <a:pPr marL="0" indent="0">
+              <a:buNone/>
+            </a:pPr>
+            <a:r>
+              <a:rPr lang="en-US" sz="1200" b="1" kern="0" spc="250" dirty="0">
+                <a:solidFill>
+                  <a:srgbClr val="FFFFFF">
+                    <a:alpha val="85000"/>
+                  </a:srgbClr>
+                </a:solidFill>
+                <a:latin typeface="Calibri" pitchFamily="34" charset="0"/>
+              </a:rPr>
+              <a:t>BTC / USDT</a:t>
+            </a:r>
+          </a:p>
+        </p:txBody>
+      </p:sp>
+      <p:cxnSp>
+        <p:nvCxnSpPr>
+          <p:cNvPr id="104" name="Grid"/>
+          <p:cNvCxnSpPr/>
+          <p:nvPr/>
+        </p:nvCxnSpPr>
+        <p:spPr>
+          <a:xfrm>
+            <a:off x="7430000" y="3227500"/>
+            <a:ext cx="4090000" cy="0"/>
+          </a:xfrm>
+          <a:prstGeom prst="line">
+            <a:avLst/>
+          </a:prstGeom>
+          <a:ln w="9525">
+            <a:solidFill>
+              <a:srgbClr val="FFFFFF">
+                <a:alpha val="10000"/>
+              </a:srgbClr>
+            </a:solidFill>
+            <a:prstDash val="dash"/>
+          </a:ln>
+        </p:spPr>
+      </p:cxnSp>
+      <p:cxnSp>
+        <p:nvCxnSpPr>
+          <p:cNvPr id="105" name="Grid"/>
+          <p:cNvCxnSpPr/>
+          <p:nvPr/>
+        </p:nvCxnSpPr>
+        <p:spPr>
+          <a:xfrm>
+            <a:off x="7430000" y="3775000"/>
+            <a:ext cx="4090000" cy="0"/>
+          </a:xfrm>
+          <a:prstGeom prst="line">
+            <a:avLst/>
+          </a:prstGeom>
+          <a:ln w="9525">
+            <a:solidFill>
+              <a:srgbClr val="FFFFFF">
+                <a:alpha val="10000"/>
+              </a:srgbClr>
+            </a:solidFill>
+            <a:prstDash val="dash"/>
+          </a:ln>
+        </p:spPr>
+      </p:cxnSp>
+      <p:cxnSp>
+        <p:nvCxnSpPr>
+          <p:cNvPr id="106" name="Grid"/>
+          <p:cNvCxnSpPr/>
+          <p:nvPr/>
+        </p:nvCxnSpPr>
+        <p:spPr>
+          <a:xfrm>
+            <a:off x="7430000" y="4322500"/>
+            <a:ext cx="4090000" cy="0"/>
+          </a:xfrm>
+          <a:prstGeom prst="line">
+            <a:avLst/>
+          </a:prstGeom>
+          <a:ln w="9525">
+            <a:solidFill>
+              <a:srgbClr val="FFFFFF">
+                <a:alpha val="10000"/>
+              </a:srgbClr>
+            </a:solidFill>
+            <a:prstDash val="dash"/>
+          </a:ln>
+        </p:spPr>
+      </p:cxnSp>
+      <p:sp>
+        <p:nvSpPr>
+          <p:cNvPr id="107" name="Wick"/>
+          <p:cNvSpPr/>
+          <p:nvPr/>
+        </p:nvSpPr>
+        <p:spPr>
+          <a:xfrm>
+            <a:off x="7641317" y="3884500"/>
+            <a:ext cx="31811" cy="810300"/>
+          </a:xfrm>
+          <a:prstGeom prst="rect">
+            <a:avLst/>
+          </a:prstGeom>
+          <a:solidFill>
+            <a:srgbClr val="E38B8B">
+              <a:alpha val="90000"/>
+            </a:srgbClr>
+          </a:solidFill>
+          <a:ln>
+            <a:noFill/>
+          </a:ln>
+        </p:spPr>
+        <p:txBody>
+          <a:bodyPr/>
+          <a:lstStyle/>
+          <a:p>
+            <a:endParaRPr lang="en-US"/>
+          </a:p>
+        </p:txBody>
+      </p:sp>
+      <p:sp>
+        <p:nvSpPr>
+          <p:cNvPr id="108" name="Body"/>
+          <p:cNvSpPr/>
+          <p:nvPr/>
+        </p:nvSpPr>
+        <p:spPr>
+          <a:xfrm>
+            <a:off x="7557245" y="4037800"/>
+            <a:ext cx="199955" cy="525600"/>
+          </a:xfrm>
+          <a:prstGeom prst="rect">
+            <a:avLst/>
+          </a:prstGeom>
+          <a:solidFill>
+            <a:srgbClr val="E38B8B">
+              <a:alpha val="90000"/>
+            </a:srgbClr>
+          </a:solidFill>
+          <a:ln>
+            <a:noFill/>
+          </a:ln>
+        </p:spPr>
+        <p:txBody>
+          <a:bodyPr/>
+          <a:lstStyle/>
+          <a:p>
+            <a:endParaRPr lang="en-US"/>
+          </a:p>
+        </p:txBody>
+      </p:sp>
+      <p:sp>
+        <p:nvSpPr>
+          <p:cNvPr id="109" name="Wick"/>
+          <p:cNvSpPr/>
+          <p:nvPr/>
+        </p:nvSpPr>
+        <p:spPr>
+          <a:xfrm>
+            <a:off x="8095761" y="3643600"/>
+            <a:ext cx="31811" cy="678900"/>
+          </a:xfrm>
+          <a:prstGeom prst="rect">
+            <a:avLst/>
+          </a:prstGeom>
+          <a:solidFill>
+            <a:srgbClr val="7DAD8C">
+              <a:alpha val="90000"/>
+            </a:srgbClr>
+          </a:solidFill>
+          <a:ln>
+            <a:noFill/>
+          </a:ln>
+        </p:spPr>
+        <p:txBody>
+          <a:bodyPr/>
+          <a:lstStyle/>
+          <a:p>
+            <a:endParaRPr lang="en-US"/>
+          </a:p>
+        </p:txBody>
+      </p:sp>
+      <p:sp>
+        <p:nvSpPr>
+          <p:cNvPr id="110" name="Body"/>
+          <p:cNvSpPr/>
+          <p:nvPr/>
+        </p:nvSpPr>
+        <p:spPr>
+          <a:xfrm>
+            <a:off x="8011689" y="3775000"/>
+            <a:ext cx="199955" cy="394200"/>
+          </a:xfrm>
+          <a:prstGeom prst="rect">
+            <a:avLst/>
+          </a:prstGeom>
+          <a:solidFill>
+            <a:srgbClr val="7DAD8C">
+              <a:alpha val="90000"/>
+            </a:srgbClr>
+          </a:solidFill>
+          <a:ln>
+            <a:noFill/>
+          </a:ln>
+        </p:spPr>
+        <p:txBody>
+          <a:bodyPr/>
+          <a:lstStyle/>
+          <a:p>
+            <a:endParaRPr lang="en-US"/>
+          </a:p>
+        </p:txBody>
+      </p:sp>
+      <p:sp>
+        <p:nvSpPr>
+          <p:cNvPr id="111" name="Wick"/>
+          <p:cNvSpPr/>
+          <p:nvPr/>
+        </p:nvSpPr>
+        <p:spPr>
+          <a:xfrm>
+            <a:off x="8550205" y="3775000"/>
+            <a:ext cx="31811" cy="657000"/>
+          </a:xfrm>
+          <a:prstGeom prst="rect">
+            <a:avLst/>
+          </a:prstGeom>
+          <a:solidFill>
+            <a:srgbClr val="E38B8B">
+              <a:alpha val="90000"/>
+            </a:srgbClr>
+          </a:solidFill>
+          <a:ln>
+            <a:noFill/>
+          </a:ln>
+        </p:spPr>
+        <p:txBody>
+          <a:bodyPr/>
+          <a:lstStyle/>
+          <a:p>
+            <a:endParaRPr lang="en-US"/>
+          </a:p>
+        </p:txBody>
+      </p:sp>
+      <p:sp>
+        <p:nvSpPr>
+          <p:cNvPr id="112" name="Body"/>
+          <p:cNvSpPr/>
+          <p:nvPr/>
+        </p:nvSpPr>
+        <p:spPr>
+          <a:xfrm>
+            <a:off x="8466133" y="3906400"/>
+            <a:ext cx="199955" cy="394199"/>
+          </a:xfrm>
+          <a:prstGeom prst="rect">
+            <a:avLst/>
+          </a:prstGeom>
+          <a:solidFill>
+            <a:srgbClr val="E38B8B">
+              <a:alpha val="90000"/>
+            </a:srgbClr>
+          </a:solidFill>
+          <a:ln>
+            <a:noFill/>
+          </a:ln>
+        </p:spPr>
+        <p:txBody>
+          <a:bodyPr/>
+          <a:lstStyle/>
+          <a:p>
+            <a:endParaRPr lang="en-US"/>
+          </a:p>
+        </p:txBody>
+      </p:sp>
+      <p:sp>
+        <p:nvSpPr>
+          <p:cNvPr id="113" name="Wick"/>
+          <p:cNvSpPr/>
+          <p:nvPr/>
+        </p:nvSpPr>
+        <p:spPr>
+          <a:xfrm>
+            <a:off x="9004649" y="3402700"/>
+            <a:ext cx="31811" cy="678900"/>
+          </a:xfrm>
+          <a:prstGeom prst="rect">
+            <a:avLst/>
+          </a:prstGeom>
+          <a:solidFill>
+            <a:srgbClr val="7DAD8C">
+              <a:alpha val="90000"/>
+            </a:srgbClr>
+          </a:solidFill>
+          <a:ln>
+            <a:noFill/>
+          </a:ln>
+        </p:spPr>
+        <p:txBody>
+          <a:bodyPr/>
+          <a:lstStyle/>
+          <a:p>
+            <a:endParaRPr lang="en-US"/>
+          </a:p>
+        </p:txBody>
+      </p:sp>
+      <p:sp>
+        <p:nvSpPr>
+          <p:cNvPr id="114" name="Body"/>
+          <p:cNvSpPr/>
+          <p:nvPr/>
+        </p:nvSpPr>
+        <p:spPr>
+          <a:xfrm>
+            <a:off x="8920577" y="3556000"/>
+            <a:ext cx="199955" cy="394199"/>
+          </a:xfrm>
+          <a:prstGeom prst="rect">
+            <a:avLst/>
+          </a:prstGeom>
+          <a:solidFill>
+            <a:srgbClr val="7DAD8C">
+              <a:alpha val="90000"/>
+            </a:srgbClr>
+          </a:solidFill>
+          <a:ln>
+            <a:noFill/>
+          </a:ln>
+        </p:spPr>
+        <p:txBody>
+          <a:bodyPr/>
+          <a:lstStyle/>
+          <a:p>
+            <a:endParaRPr lang="en-US"/>
+          </a:p>
+        </p:txBody>
+      </p:sp>
+      <p:sp>
+        <p:nvSpPr>
+          <p:cNvPr id="115" name="Wick"/>
+          <p:cNvSpPr/>
+          <p:nvPr/>
+        </p:nvSpPr>
+        <p:spPr>
+          <a:xfrm>
+            <a:off x="9459093" y="3556000"/>
+            <a:ext cx="31811" cy="613200"/>
+          </a:xfrm>
+          <a:prstGeom prst="rect">
+            <a:avLst/>
+          </a:prstGeom>
+          <a:solidFill>
+            <a:srgbClr val="E38B8B">
+              <a:alpha val="90000"/>
+            </a:srgbClr>
+          </a:solidFill>
+          <a:ln>
+            <a:noFill/>
+          </a:ln>
+        </p:spPr>
+        <p:txBody>
+          <a:bodyPr/>
+          <a:lstStyle/>
+          <a:p>
+            <a:endParaRPr lang="en-US"/>
+          </a:p>
+        </p:txBody>
+      </p:sp>
+      <p:sp>
+        <p:nvSpPr>
+          <p:cNvPr id="116" name="Body"/>
+          <p:cNvSpPr/>
+          <p:nvPr/>
+        </p:nvSpPr>
+        <p:spPr>
+          <a:xfrm>
+            <a:off x="9375021" y="3687400"/>
+            <a:ext cx="199955" cy="350399"/>
+          </a:xfrm>
+          <a:prstGeom prst="rect">
+            <a:avLst/>
+          </a:prstGeom>
+          <a:solidFill>
+            <a:srgbClr val="E38B8B">
+              <a:alpha val="90000"/>
+            </a:srgbClr>
+          </a:solidFill>
+          <a:ln>
+            <a:noFill/>
+          </a:ln>
+        </p:spPr>
+        <p:txBody>
+          <a:bodyPr/>
+          <a:lstStyle/>
+          <a:p>
+            <a:endParaRPr lang="en-US"/>
+          </a:p>
+        </p:txBody>
+      </p:sp>
+      <p:sp>
+        <p:nvSpPr>
+          <p:cNvPr id="117" name="Wick"/>
+          <p:cNvSpPr/>
+          <p:nvPr/>
+        </p:nvSpPr>
+        <p:spPr>
+          <a:xfrm>
+            <a:off x="9913537" y="3205600"/>
+            <a:ext cx="31811" cy="657000"/>
+          </a:xfrm>
+          <a:prstGeom prst="rect">
+            <a:avLst/>
+          </a:prstGeom>
+          <a:solidFill>
+            <a:srgbClr val="7DAD8C">
+              <a:alpha val="90000"/>
+            </a:srgbClr>
+          </a:solidFill>
+          <a:ln>
+            <a:noFill/>
+          </a:ln>
+        </p:spPr>
+        <p:txBody>
+          <a:bodyPr/>
+          <a:lstStyle/>
+          <a:p>
+            <a:endParaRPr lang="en-US"/>
+          </a:p>
+        </p:txBody>
+      </p:sp>
+      <p:sp>
+        <p:nvSpPr>
+          <p:cNvPr id="118" name="Body"/>
+          <p:cNvSpPr/>
+          <p:nvPr/>
+        </p:nvSpPr>
+        <p:spPr>
+          <a:xfrm>
+            <a:off x="9829465" y="3337000"/>
+            <a:ext cx="199955" cy="394200"/>
+          </a:xfrm>
+          <a:prstGeom prst="rect">
+            <a:avLst/>
+          </a:prstGeom>
+          <a:solidFill>
+            <a:srgbClr val="7DAD8C">
+              <a:alpha val="90000"/>
+            </a:srgbClr>
+          </a:solidFill>
+          <a:ln>
+            <a:noFill/>
+          </a:ln>
+        </p:spPr>
+        <p:txBody>
+          <a:bodyPr/>
+          <a:lstStyle/>
+          <a:p>
+            <a:endParaRPr lang="en-US"/>
+          </a:p>
+        </p:txBody>
+      </p:sp>
+      <p:sp>
+        <p:nvSpPr>
+          <p:cNvPr id="119" name="Wick"/>
+          <p:cNvSpPr/>
+          <p:nvPr/>
+        </p:nvSpPr>
+        <p:spPr>
+          <a:xfrm>
+            <a:off x="10367981" y="3337000"/>
+            <a:ext cx="31811" cy="569400"/>
+          </a:xfrm>
+          <a:prstGeom prst="rect">
+            <a:avLst/>
+          </a:prstGeom>
+          <a:solidFill>
+            <a:srgbClr val="E38B8B">
+              <a:alpha val="90000"/>
+            </a:srgbClr>
+          </a:solidFill>
+          <a:ln>
+            <a:noFill/>
+          </a:ln>
+        </p:spPr>
+        <p:txBody>
+          <a:bodyPr/>
+          <a:lstStyle/>
+          <a:p>
+            <a:endParaRPr lang="en-US"/>
+          </a:p>
+        </p:txBody>
+      </p:sp>
+      <p:sp>
+        <p:nvSpPr>
+          <p:cNvPr id="120" name="Body"/>
+          <p:cNvSpPr/>
+          <p:nvPr/>
+        </p:nvSpPr>
+        <p:spPr>
+          <a:xfrm>
+            <a:off x="10283909" y="3468400"/>
+            <a:ext cx="199955" cy="306600"/>
+          </a:xfrm>
+          <a:prstGeom prst="rect">
+            <a:avLst/>
+          </a:prstGeom>
+          <a:solidFill>
+            <a:srgbClr val="E38B8B">
+              <a:alpha val="90000"/>
+            </a:srgbClr>
+          </a:solidFill>
+          <a:ln>
+            <a:noFill/>
+          </a:ln>
+        </p:spPr>
+        <p:txBody>
+          <a:bodyPr/>
+          <a:lstStyle/>
+          <a:p>
+            <a:endParaRPr lang="en-US"/>
+          </a:p>
+        </p:txBody>
+      </p:sp>
+      <p:sp>
+        <p:nvSpPr>
+          <p:cNvPr id="121" name="Wick"/>
+          <p:cNvSpPr/>
+          <p:nvPr/>
+        </p:nvSpPr>
+        <p:spPr>
+          <a:xfrm>
+            <a:off x="10822425" y="2899000"/>
+            <a:ext cx="31811" cy="657000"/>
+          </a:xfrm>
+          <a:prstGeom prst="rect">
+            <a:avLst/>
+          </a:prstGeom>
+          <a:solidFill>
+            <a:srgbClr val="7DAD8C">
+              <a:alpha val="90000"/>
+            </a:srgbClr>
+          </a:solidFill>
+          <a:ln>
+            <a:noFill/>
+          </a:ln>
+        </p:spPr>
+        <p:txBody>
+          <a:bodyPr/>
+          <a:lstStyle/>
+          <a:p>
+            <a:endParaRPr lang="en-US"/>
+          </a:p>
+        </p:txBody>
+      </p:sp>
+      <p:sp>
+        <p:nvSpPr>
+          <p:cNvPr id="122" name="Body"/>
+          <p:cNvSpPr/>
+          <p:nvPr/>
+        </p:nvSpPr>
+        <p:spPr>
+          <a:xfrm>
+            <a:off x="10738353" y="3030400"/>
+            <a:ext cx="199955" cy="394200"/>
+          </a:xfrm>
+          <a:prstGeom prst="rect">
+            <a:avLst/>
+          </a:prstGeom>
+          <a:solidFill>
+            <a:srgbClr val="7DAD8C">
+              <a:alpha val="90000"/>
+            </a:srgbClr>
+          </a:solidFill>
+          <a:ln>
+            <a:noFill/>
+          </a:ln>
+        </p:spPr>
+        <p:txBody>
+          <a:bodyPr/>
+          <a:lstStyle/>
+          <a:p>
+            <a:endParaRPr lang="en-US"/>
+          </a:p>
+        </p:txBody>
+      </p:sp>
+      <p:sp>
+        <p:nvSpPr>
+          <p:cNvPr id="123" name="Wick"/>
+          <p:cNvSpPr/>
+          <p:nvPr/>
+        </p:nvSpPr>
+        <p:spPr>
+          <a:xfrm>
+            <a:off x="11276869" y="2680000"/>
+            <a:ext cx="31811" cy="613200"/>
+          </a:xfrm>
+          <a:prstGeom prst="rect">
+            <a:avLst/>
+          </a:prstGeom>
+          <a:solidFill>
+            <a:srgbClr val="7DAD8C">
+              <a:alpha val="90000"/>
+            </a:srgbClr>
+          </a:solidFill>
+          <a:ln>
+            <a:noFill/>
+          </a:ln>
+        </p:spPr>
+        <p:txBody>
+          <a:bodyPr/>
+          <a:lstStyle/>
+          <a:p>
+            <a:endParaRPr lang="en-US"/>
+          </a:p>
+        </p:txBody>
+      </p:sp>
+      <p:sp>
+        <p:nvSpPr>
+          <p:cNvPr id="124" name="Body"/>
+          <p:cNvSpPr/>
+          <p:nvPr/>
+        </p:nvSpPr>
+        <p:spPr>
+          <a:xfrm>
+            <a:off x="11192797" y="2767600"/>
+            <a:ext cx="199955" cy="394200"/>
+          </a:xfrm>
+          <a:prstGeom prst="rect">
+            <a:avLst/>
+          </a:prstGeom>
+          <a:solidFill>
+            <a:srgbClr val="7DAD8C">
+              <a:alpha val="90000"/>
+            </a:srgbClr>
+          </a:solidFill>
+          <a:ln>
+            <a:noFill/>
+          </a:ln>
+        </p:spPr>
+        <p:txBody>
+          <a:bodyPr/>
+          <a:lstStyle/>
+          <a:p>
+            <a:endParaRPr lang="en-US"/>
+          </a:p>
+        </p:txBody>
+      </p:sp>
+      <p:cxnSp>
+        <p:nvCxnSpPr>
+          <p:cNvPr id="125" name="Trend"/>
+          <p:cNvCxnSpPr/>
+          <p:nvPr/>
+        </p:nvCxnSpPr>
+        <p:spPr>
+          <a:xfrm flipV="1">
+            <a:off x="7657222" y="3972100"/>
+            <a:ext cx="454444" cy="328500"/>
+          </a:xfrm>
+          <a:prstGeom prst="line">
+            <a:avLst/>
+          </a:prstGeom>
+          <a:ln w="19050">
+            <a:solidFill>
+              <a:srgbClr val="FFFFFF">
+                <a:alpha val="55000"/>
+              </a:srgbClr>
+            </a:solidFill>
+            <a:round/>
+          </a:ln>
+        </p:spPr>
+      </p:cxnSp>
+      <p:cxnSp>
+        <p:nvCxnSpPr>
+          <p:cNvPr id="126" name="Trend"/>
+          <p:cNvCxnSpPr/>
+          <p:nvPr/>
+        </p:nvCxnSpPr>
+        <p:spPr>
+          <a:xfrm>
+            <a:off x="8111666" y="3972100"/>
+            <a:ext cx="454444" cy="131400"/>
+          </a:xfrm>
+          <a:prstGeom prst="line">
+            <a:avLst/>
+          </a:prstGeom>
+          <a:ln w="19050">
+            <a:solidFill>
+              <a:srgbClr val="FFFFFF">
+                <a:alpha val="55000"/>
+              </a:srgbClr>
+            </a:solidFill>
+            <a:round/>
+          </a:ln>
+        </p:spPr>
+      </p:cxnSp>
+      <p:cxnSp>
+        <p:nvCxnSpPr>
+          <p:cNvPr id="127" name="Trend"/>
+          <p:cNvCxnSpPr/>
+          <p:nvPr/>
+        </p:nvCxnSpPr>
+        <p:spPr>
+          <a:xfrm flipV="1">
+            <a:off x="8566110" y="3753100"/>
+            <a:ext cx="454444" cy="350400"/>
+          </a:xfrm>
+          <a:prstGeom prst="line">
+            <a:avLst/>
+          </a:prstGeom>
+          <a:ln w="19050">
+            <a:solidFill>
+              <a:srgbClr val="FFFFFF">
+                <a:alpha val="55000"/>
+              </a:srgbClr>
+            </a:solidFill>
+            <a:round/>
+          </a:ln>
+        </p:spPr>
+      </p:cxnSp>
+      <p:cxnSp>
+        <p:nvCxnSpPr>
+          <p:cNvPr id="128" name="Trend"/>
+          <p:cNvCxnSpPr/>
+          <p:nvPr/>
+        </p:nvCxnSpPr>
+        <p:spPr>
+          <a:xfrm>
+            <a:off x="9020554" y="3753100"/>
+            <a:ext cx="454444" cy="109500"/>
+          </a:xfrm>
+          <a:prstGeom prst="line">
+            <a:avLst/>
+          </a:prstGeom>
+          <a:ln w="19050">
+            <a:solidFill>
+              <a:srgbClr val="FFFFFF">
+                <a:alpha val="55000"/>
+              </a:srgbClr>
+            </a:solidFill>
+            <a:round/>
+          </a:ln>
+        </p:spPr>
+      </p:cxnSp>
+      <p:cxnSp>
+        <p:nvCxnSpPr>
+          <p:cNvPr id="129" name="Trend"/>
+          <p:cNvCxnSpPr/>
+          <p:nvPr/>
+        </p:nvCxnSpPr>
+        <p:spPr>
+          <a:xfrm flipV="1">
+            <a:off x="9474998" y="3534100"/>
+            <a:ext cx="454444" cy="328500"/>
+          </a:xfrm>
+          <a:prstGeom prst="line">
+            <a:avLst/>
+          </a:prstGeom>
+          <a:ln w="19050">
+            <a:solidFill>
+              <a:srgbClr val="FFFFFF">
+                <a:alpha val="55000"/>
+              </a:srgbClr>
+            </a:solidFill>
+            <a:round/>
+          </a:ln>
+        </p:spPr>
+      </p:cxnSp>
+      <p:cxnSp>
+        <p:nvCxnSpPr>
+          <p:cNvPr id="130" name="Trend"/>
+          <p:cNvCxnSpPr/>
+          <p:nvPr/>
+        </p:nvCxnSpPr>
+        <p:spPr>
+          <a:xfrm>
+            <a:off x="9929442" y="3534100"/>
+            <a:ext cx="454444" cy="87600"/>
+          </a:xfrm>
+          <a:prstGeom prst="line">
+            <a:avLst/>
+          </a:prstGeom>
+          <a:ln w="19050">
+            <a:solidFill>
+              <a:srgbClr val="FFFFFF">
+                <a:alpha val="55000"/>
+              </a:srgbClr>
+            </a:solidFill>
+            <a:round/>
+          </a:ln>
+        </p:spPr>
+      </p:cxnSp>
+      <p:cxnSp>
+        <p:nvCxnSpPr>
+          <p:cNvPr id="131" name="Trend"/>
+          <p:cNvCxnSpPr/>
+          <p:nvPr/>
+        </p:nvCxnSpPr>
+        <p:spPr>
+          <a:xfrm flipV="1">
+            <a:off x="10383886" y="3227500"/>
+            <a:ext cx="454444" cy="394200"/>
+          </a:xfrm>
+          <a:prstGeom prst="line">
+            <a:avLst/>
+          </a:prstGeom>
+          <a:ln w="19050">
+            <a:solidFill>
+              <a:srgbClr val="FFFFFF">
+                <a:alpha val="55000"/>
+              </a:srgbClr>
+            </a:solidFill>
+            <a:round/>
+          </a:ln>
+        </p:spPr>
+      </p:cxnSp>
+      <p:cxnSp>
+        <p:nvCxnSpPr>
+          <p:cNvPr id="132" name="Trend"/>
+          <p:cNvCxnSpPr/>
+          <p:nvPr/>
+        </p:nvCxnSpPr>
+        <p:spPr>
+          <a:xfrm flipV="1">
+            <a:off x="10838330" y="2964700"/>
+            <a:ext cx="454444" cy="262800"/>
+          </a:xfrm>
+          <a:prstGeom prst="line">
+            <a:avLst/>
+          </a:prstGeom>
+          <a:ln w="19050">
+            <a:solidFill>
+              <a:srgbClr val="FFFFFF">
+                <a:alpha val="55000"/>
+              </a:srgbClr>
+            </a:solidFill>
+            <a:round/>
+          </a:ln>
+        </p:spPr>
+      </p:cxnSp>
+      <p:cxnSp>
+        <p:nvCxnSpPr>
+          <p:cNvPr id="133" name="Baseline"/>
+          <p:cNvCxnSpPr/>
+          <p:nvPr/>
+        </p:nvCxnSpPr>
+        <p:spPr>
+          <a:xfrm>
+            <a:off x="7430000" y="4930000"/>
+            <a:ext cx="4090000" cy="0"/>
+          </a:xfrm>
+          <a:prstGeom prst="line">
+            <a:avLst/>
+          </a:prstGeom>
+          <a:ln w="9525">
+            <a:solidFill>
+              <a:srgbClr val="FFFFFF">
+                <a:alpha val="20000"/>
+              </a:srgbClr>
+            </a:solidFill>
+          </a:ln>
+        </p:spPr>
+      </p:cxnSp>
     </p:spTree>
   </p:cSld>
   <p:clrMapOvr>
@@ -2463,14 +3383,14 @@
       </p:sp>
       <p:sp>
         <p:nvSpPr>
-          <p:cNvPr id="4" name="Shape 2"/>
+          <p:cNvPr id="100" name="Panel"/>
           <p:cNvSpPr/>
           <p:nvPr/>
         </p:nvSpPr>
         <p:spPr>
           <a:xfrm>
             <a:off x="822960" y="1874520"/>
-            <a:ext cx="5097780" cy="4114800"/>
+            <a:ext cx="5097780" cy="4762104"/>
           </a:xfrm>
           <a:prstGeom prst="roundRect">
             <a:avLst>
@@ -2486,20 +3406,20 @@
           <a:bodyPr/>
           <a:lstStyle/>
           <a:p>
-            <a:endParaRPr lang="LID4096" dirty="0"/>
-          </a:p>
-        </p:txBody>
-      </p:sp>
-      <p:sp>
-        <p:nvSpPr>
-          <p:cNvPr id="5" name="Shape 3"/>
-          <p:cNvSpPr/>
-          <p:nvPr/>
-        </p:nvSpPr>
-        <p:spPr>
-          <a:xfrm>
-            <a:off x="1188720" y="2240280"/>
-            <a:ext cx="658368" cy="658368"/>
+            <a:endParaRPr lang="en-US" dirty="0"/>
+          </a:p>
+        </p:txBody>
+      </p:sp>
+      <p:sp>
+        <p:nvSpPr>
+          <p:cNvPr id="101" name="HeaderCircle"/>
+          <p:cNvSpPr/>
+          <p:nvPr/>
+        </p:nvSpPr>
+        <p:spPr>
+          <a:xfrm>
+            <a:off x="1188720" y="2174520"/>
+            <a:ext cx="560000" cy="560000"/>
           </a:xfrm>
           <a:prstGeom prst="ellipse">
             <a:avLst/>
@@ -2519,7 +3439,7 @@
       </p:sp>
       <p:pic>
         <p:nvPicPr>
-          <p:cNvPr id="6" name="Image 0" descr="/home/claude/cryptosight_ppt/icons/clock_FFFFFF.png"/>
+          <p:cNvPr id="102" name="Image" descr="clock icon"/>
           <p:cNvPicPr>
             <a:picLocks noChangeAspect="1"/>
           </p:cNvPicPr>
@@ -2533,8 +3453,8 @@
         </p:blipFill>
         <p:spPr>
           <a:xfrm>
-            <a:off x="1346728" y="2398288"/>
-            <a:ext cx="342351" cy="342351"/>
+            <a:off x="1323720" y="2309520"/>
+            <a:ext cx="290000" cy="290000"/>
           </a:xfrm>
           <a:prstGeom prst="rect">
             <a:avLst/>
@@ -2543,13 +3463,13 @@
       </p:pic>
       <p:sp>
         <p:nvSpPr>
-          <p:cNvPr id="7" name="Text 4"/>
-          <p:cNvSpPr/>
-          <p:nvPr/>
-        </p:nvSpPr>
-        <p:spPr>
-          <a:xfrm>
-            <a:off x="1188720" y="3044952"/>
+          <p:cNvPr id="103" name="Label"/>
+          <p:cNvSpPr/>
+          <p:nvPr/>
+        </p:nvSpPr>
+        <p:spPr>
+          <a:xfrm>
+            <a:off x="1188720" y="2844520"/>
             <a:ext cx="4366260" cy="292608"/>
           </a:xfrm>
           <a:prstGeom prst="rect">
@@ -2566,7 +3486,7 @@
               <a:buNone/>
             </a:pPr>
             <a:r>
-              <a:rPr lang="en-US" sz="1100" b="1" kern="0" spc="300" dirty="0">
+              <a:rPr lang="en-US" sz="1100" b="1" kern="0" spc="200" dirty="0">
                 <a:solidFill>
                   <a:srgbClr val="EE5D5D"/>
                 </a:solidFill>
@@ -2582,13 +3502,13 @@
       </p:sp>
       <p:sp>
         <p:nvSpPr>
-          <p:cNvPr id="8" name="Shape 5"/>
-          <p:cNvSpPr/>
-          <p:nvPr/>
-        </p:nvSpPr>
-        <p:spPr>
-          <a:xfrm>
-            <a:off x="1188720" y="3474720"/>
+          <p:cNvPr id="104" name="RowCircle"/>
+          <p:cNvSpPr/>
+          <p:nvPr/>
+        </p:nvSpPr>
+        <p:spPr>
+          <a:xfrm>
+            <a:off x="1188720" y="3247128"/>
             <a:ext cx="457200" cy="457200"/>
           </a:xfrm>
           <a:prstGeom prst="ellipse">
@@ -2609,7 +3529,7 @@
       </p:sp>
       <p:pic>
         <p:nvPicPr>
-          <p:cNvPr id="9" name="Image 1" descr="/home/claude/cryptosight_ppt/icons/xcircle_EE5D5D.png"/>
+          <p:cNvPr id="105" name="Image" descr="xcircle icon"/>
           <p:cNvPicPr>
             <a:picLocks noChangeAspect="1"/>
           </p:cNvPicPr>
@@ -2623,7 +3543,7 @@
         </p:blipFill>
         <p:spPr>
           <a:xfrm>
-            <a:off x="1298448" y="3584448"/>
+            <a:off x="1298448" y="3356856"/>
             <a:ext cx="237744" cy="237744"/>
           </a:xfrm>
           <a:prstGeom prst="rect">
@@ -2633,13 +3553,13 @@
       </p:pic>
       <p:sp>
         <p:nvSpPr>
-          <p:cNvPr id="10" name="Text 6"/>
-          <p:cNvSpPr/>
-          <p:nvPr/>
-        </p:nvSpPr>
-        <p:spPr>
-          <a:xfrm>
-            <a:off x="1783080" y="3419856"/>
+          <p:cNvPr id="106" name="RowText"/>
+          <p:cNvSpPr/>
+          <p:nvPr/>
+        </p:nvSpPr>
+        <p:spPr>
+          <a:xfrm>
+            <a:off x="1783080" y="3192264"/>
             <a:ext cx="3771900" cy="594360"/>
           </a:xfrm>
           <a:prstGeom prst="rect">
@@ -2656,7 +3576,7 @@
               <a:buNone/>
             </a:pPr>
             <a:r>
-              <a:rPr lang="en-US" sz="1450" dirty="0">
+              <a:rPr lang="en-US" sz="1350" dirty="0">
                 <a:solidFill>
                   <a:srgbClr val="1B2A21"/>
                 </a:solidFill>
@@ -2666,19 +3586,19 @@
               </a:rPr>
               <a:t>Can't watch charts 24/7</a:t>
             </a:r>
-            <a:endParaRPr lang="en-US" sz="1450" dirty="0"/>
-          </a:p>
-        </p:txBody>
-      </p:sp>
-      <p:sp>
-        <p:nvSpPr>
-          <p:cNvPr id="11" name="Shape 7"/>
-          <p:cNvSpPr/>
-          <p:nvPr/>
-        </p:nvSpPr>
-        <p:spPr>
-          <a:xfrm>
-            <a:off x="1188720" y="4251960"/>
+            <a:endParaRPr lang="en-US" sz="1350" dirty="0"/>
+          </a:p>
+        </p:txBody>
+      </p:sp>
+      <p:sp>
+        <p:nvSpPr>
+          <p:cNvPr id="107" name="RowCircle"/>
+          <p:cNvSpPr/>
+          <p:nvPr/>
+        </p:nvSpPr>
+        <p:spPr>
+          <a:xfrm>
+            <a:off x="1188720" y="3897128"/>
             <a:ext cx="457200" cy="457200"/>
           </a:xfrm>
           <a:prstGeom prst="ellipse">
@@ -2699,7 +3619,7 @@
       </p:sp>
       <p:pic>
         <p:nvPicPr>
-          <p:cNvPr id="12" name="Image 2" descr="/home/claude/cryptosight_ppt/icons/xcircle_EE5D5D.png"/>
+          <p:cNvPr id="108" name="Image" descr="xcircle icon"/>
           <p:cNvPicPr>
             <a:picLocks noChangeAspect="1"/>
           </p:cNvPicPr>
@@ -2713,7 +3633,7 @@
         </p:blipFill>
         <p:spPr>
           <a:xfrm>
-            <a:off x="1298448" y="4361688"/>
+            <a:off x="1298448" y="4006856"/>
             <a:ext cx="237744" cy="237744"/>
           </a:xfrm>
           <a:prstGeom prst="rect">
@@ -2723,13 +3643,13 @@
       </p:pic>
       <p:sp>
         <p:nvSpPr>
-          <p:cNvPr id="13" name="Text 8"/>
-          <p:cNvSpPr/>
-          <p:nvPr/>
-        </p:nvSpPr>
-        <p:spPr>
-          <a:xfrm>
-            <a:off x="1783080" y="4197096"/>
+          <p:cNvPr id="109" name="RowText"/>
+          <p:cNvSpPr/>
+          <p:nvPr/>
+        </p:nvSpPr>
+        <p:spPr>
+          <a:xfrm>
+            <a:off x="1783080" y="3842264"/>
             <a:ext cx="3771900" cy="594360"/>
           </a:xfrm>
           <a:prstGeom prst="rect">
@@ -2746,7 +3666,7 @@
               <a:buNone/>
             </a:pPr>
             <a:r>
-              <a:rPr lang="en-US" sz="1450" dirty="0">
+              <a:rPr lang="en-US" sz="1350" dirty="0">
                 <a:solidFill>
                   <a:srgbClr val="1B2A21"/>
                 </a:solidFill>
@@ -2756,19 +3676,19 @@
               </a:rPr>
               <a:t>Too many indicators to track manually</a:t>
             </a:r>
-            <a:endParaRPr lang="en-US" sz="1450" dirty="0"/>
-          </a:p>
-        </p:txBody>
-      </p:sp>
-      <p:sp>
-        <p:nvSpPr>
-          <p:cNvPr id="14" name="Shape 9"/>
-          <p:cNvSpPr/>
-          <p:nvPr/>
-        </p:nvSpPr>
-        <p:spPr>
-          <a:xfrm>
-            <a:off x="1188720" y="5029200"/>
+            <a:endParaRPr lang="en-US" sz="1350" dirty="0"/>
+          </a:p>
+        </p:txBody>
+      </p:sp>
+      <p:sp>
+        <p:nvSpPr>
+          <p:cNvPr id="110" name="RowCircle"/>
+          <p:cNvSpPr/>
+          <p:nvPr/>
+        </p:nvSpPr>
+        <p:spPr>
+          <a:xfrm>
+            <a:off x="1188720" y="4547128"/>
             <a:ext cx="457200" cy="457200"/>
           </a:xfrm>
           <a:prstGeom prst="ellipse">
@@ -2789,7 +3709,7 @@
       </p:sp>
       <p:pic>
         <p:nvPicPr>
-          <p:cNvPr id="15" name="Image 3" descr="/home/claude/cryptosight_ppt/icons/xcircle_EE5D5D.png"/>
+          <p:cNvPr id="111" name="Image" descr="xcircle icon"/>
           <p:cNvPicPr>
             <a:picLocks noChangeAspect="1"/>
           </p:cNvPicPr>
@@ -2803,7 +3723,7 @@
         </p:blipFill>
         <p:spPr>
           <a:xfrm>
-            <a:off x="1298448" y="5138928"/>
+            <a:off x="1298448" y="4656856"/>
             <a:ext cx="237744" cy="237744"/>
           </a:xfrm>
           <a:prstGeom prst="rect">
@@ -2813,13 +3733,13 @@
       </p:pic>
       <p:sp>
         <p:nvSpPr>
-          <p:cNvPr id="16" name="Text 10"/>
-          <p:cNvSpPr/>
-          <p:nvPr/>
-        </p:nvSpPr>
-        <p:spPr>
-          <a:xfrm>
-            <a:off x="1783080" y="4974336"/>
+          <p:cNvPr id="112" name="RowText"/>
+          <p:cNvSpPr/>
+          <p:nvPr/>
+        </p:nvSpPr>
+        <p:spPr>
+          <a:xfrm>
+            <a:off x="1783080" y="4492264"/>
             <a:ext cx="3771900" cy="594360"/>
           </a:xfrm>
           <a:prstGeom prst="rect">
@@ -2836,7 +3756,7 @@
               <a:buNone/>
             </a:pPr>
             <a:r>
-              <a:rPr lang="en-US" sz="1450" dirty="0">
+              <a:rPr lang="en-US" sz="1350" dirty="0">
                 <a:solidFill>
                   <a:srgbClr val="1B2A21"/>
                 </a:solidFill>
@@ -2846,20 +3766,200 @@
               </a:rPr>
               <a:t>Signals missed = opportunities lost</a:t>
             </a:r>
-            <a:endParaRPr lang="en-US" sz="1450" dirty="0"/>
-          </a:p>
-        </p:txBody>
-      </p:sp>
-      <p:sp>
-        <p:nvSpPr>
-          <p:cNvPr id="17" name="Shape 11"/>
+            <a:endParaRPr lang="en-US" sz="1350" dirty="0"/>
+          </a:p>
+        </p:txBody>
+      </p:sp>
+      <p:sp>
+        <p:nvSpPr>
+          <p:cNvPr id="113" name="RowCircle"/>
+          <p:cNvSpPr/>
+          <p:nvPr/>
+        </p:nvSpPr>
+        <p:spPr>
+          <a:xfrm>
+            <a:off x="1188720" y="5197128"/>
+            <a:ext cx="457200" cy="457200"/>
+          </a:xfrm>
+          <a:prstGeom prst="ellipse">
+            <a:avLst/>
+          </a:prstGeom>
+          <a:solidFill>
+            <a:srgbClr val="FFFFFF"/>
+          </a:solidFill>
+          <a:ln/>
+          <a:effectLst>
+            <a:outerShdw blurRad="127000" dist="38100" dir="5400000" algn="bl" rotWithShape="0">
+              <a:srgbClr val="1B2A21">
+                <a:alpha val="16000"/>
+              </a:srgbClr>
+            </a:outerShdw>
+          </a:effectLst>
+        </p:spPr>
+      </p:sp>
+      <p:pic>
+        <p:nvPicPr>
+          <p:cNvPr id="114" name="Image" descr="xcircle icon"/>
+          <p:cNvPicPr>
+            <a:picLocks noChangeAspect="1"/>
+          </p:cNvPicPr>
+          <p:nvPr/>
+        </p:nvPicPr>
+        <p:blipFill>
+          <a:blip r:embed="rId5"/>
+          <a:stretch>
+            <a:fillRect/>
+          </a:stretch>
+        </p:blipFill>
+        <p:spPr>
+          <a:xfrm>
+            <a:off x="1298448" y="5306856"/>
+            <a:ext cx="237744" cy="237744"/>
+          </a:xfrm>
+          <a:prstGeom prst="rect">
+            <a:avLst/>
+          </a:prstGeom>
+        </p:spPr>
+      </p:pic>
+      <p:sp>
+        <p:nvSpPr>
+          <p:cNvPr id="115" name="RowText"/>
+          <p:cNvSpPr/>
+          <p:nvPr/>
+        </p:nvSpPr>
+        <p:spPr>
+          <a:xfrm>
+            <a:off x="1783080" y="5142264"/>
+            <a:ext cx="3771900" cy="594360"/>
+          </a:xfrm>
+          <a:prstGeom prst="rect">
+            <a:avLst/>
+          </a:prstGeom>
+          <a:noFill/>
+          <a:ln/>
+        </p:spPr>
+        <p:txBody>
+          <a:bodyPr wrap="square" lIns="0" tIns="0" rIns="0" bIns="0" rtlCol="0" anchor="ctr"/>
+          <a:lstStyle/>
+          <a:p>
+            <a:pPr marL="0" indent="0">
+              <a:buNone/>
+            </a:pPr>
+            <a:r>
+              <a:rPr lang="en-US" sz="1350" dirty="0">
+                <a:solidFill>
+                  <a:srgbClr val="1B2A21"/>
+                </a:solidFill>
+                <a:latin typeface="Calibri" pitchFamily="34" charset="0"/>
+                <a:ea typeface="Calibri" pitchFamily="34" charset="-122"/>
+                <a:cs typeface="Calibri" pitchFamily="34" charset="-120"/>
+              </a:rPr>
+              <a:t>Trades placed on gut feeling, not a tested strategy</a:t>
+            </a:r>
+            <a:endParaRPr lang="en-US" sz="1350" dirty="0"/>
+          </a:p>
+        </p:txBody>
+      </p:sp>
+      <p:sp>
+        <p:nvSpPr>
+          <p:cNvPr id="116" name="RowCircle"/>
+          <p:cNvSpPr/>
+          <p:nvPr/>
+        </p:nvSpPr>
+        <p:spPr>
+          <a:xfrm>
+            <a:off x="1188720" y="5847128"/>
+            <a:ext cx="457200" cy="457200"/>
+          </a:xfrm>
+          <a:prstGeom prst="ellipse">
+            <a:avLst/>
+          </a:prstGeom>
+          <a:solidFill>
+            <a:srgbClr val="FFFFFF"/>
+          </a:solidFill>
+          <a:ln/>
+          <a:effectLst>
+            <a:outerShdw blurRad="127000" dist="38100" dir="5400000" algn="bl" rotWithShape="0">
+              <a:srgbClr val="1B2A21">
+                <a:alpha val="16000"/>
+              </a:srgbClr>
+            </a:outerShdw>
+          </a:effectLst>
+        </p:spPr>
+      </p:sp>
+      <p:pic>
+        <p:nvPicPr>
+          <p:cNvPr id="117" name="Image" descr="xcircle icon"/>
+          <p:cNvPicPr>
+            <a:picLocks noChangeAspect="1"/>
+          </p:cNvPicPr>
+          <p:nvPr/>
+        </p:nvPicPr>
+        <p:blipFill>
+          <a:blip r:embed="rId5"/>
+          <a:stretch>
+            <a:fillRect/>
+          </a:stretch>
+        </p:blipFill>
+        <p:spPr>
+          <a:xfrm>
+            <a:off x="1298448" y="5956856"/>
+            <a:ext cx="237744" cy="237744"/>
+          </a:xfrm>
+          <a:prstGeom prst="rect">
+            <a:avLst/>
+          </a:prstGeom>
+        </p:spPr>
+      </p:pic>
+      <p:sp>
+        <p:nvSpPr>
+          <p:cNvPr id="118" name="RowText"/>
+          <p:cNvSpPr/>
+          <p:nvPr/>
+        </p:nvSpPr>
+        <p:spPr>
+          <a:xfrm>
+            <a:off x="1783080" y="5792264"/>
+            <a:ext cx="3771900" cy="594360"/>
+          </a:xfrm>
+          <a:prstGeom prst="rect">
+            <a:avLst/>
+          </a:prstGeom>
+          <a:noFill/>
+          <a:ln/>
+        </p:spPr>
+        <p:txBody>
+          <a:bodyPr wrap="square" lIns="0" tIns="0" rIns="0" bIns="0" rtlCol="0" anchor="ctr"/>
+          <a:lstStyle/>
+          <a:p>
+            <a:pPr marL="0" indent="0">
+              <a:buNone/>
+            </a:pPr>
+            <a:r>
+              <a:rPr lang="en-US" sz="1350" dirty="0">
+                <a:solidFill>
+                  <a:srgbClr val="1B2A21"/>
+                </a:solidFill>
+                <a:latin typeface="Calibri" pitchFamily="34" charset="0"/>
+                <a:ea typeface="Calibri" pitchFamily="34" charset="-122"/>
+                <a:cs typeface="Calibri" pitchFamily="34" charset="-120"/>
+              </a:rPr>
+              <a:t>No way to compare strategies before risking capital</a:t>
+            </a:r>
+            <a:endParaRPr lang="en-US" sz="1350" dirty="0"/>
+          </a:p>
+        </p:txBody>
+      </p:sp>
+      <p:sp>
+        <p:nvSpPr>
+          <p:cNvPr id="119" name="Panel"/>
           <p:cNvSpPr/>
           <p:nvPr/>
         </p:nvSpPr>
         <p:spPr>
           <a:xfrm>
             <a:off x="6286500" y="1874520"/>
-            <a:ext cx="5097780" cy="4114800"/>
+            <a:ext cx="5097780" cy="4762104"/>
           </a:xfrm>
           <a:prstGeom prst="roundRect">
             <a:avLst>
@@ -2878,17 +3978,24 @@
             </a:outerShdw>
           </a:effectLst>
         </p:spPr>
-      </p:sp>
-      <p:sp>
-        <p:nvSpPr>
-          <p:cNvPr id="18" name="Shape 12"/>
-          <p:cNvSpPr/>
-          <p:nvPr/>
-        </p:nvSpPr>
-        <p:spPr>
-          <a:xfrm>
-            <a:off x="6652260" y="2240280"/>
-            <a:ext cx="658368" cy="658368"/>
+        <p:txBody>
+          <a:bodyPr/>
+          <a:lstStyle/>
+          <a:p>
+            <a:endParaRPr lang="en-US" dirty="0"/>
+          </a:p>
+        </p:txBody>
+      </p:sp>
+      <p:sp>
+        <p:nvSpPr>
+          <p:cNvPr id="120" name="HeaderCircle"/>
+          <p:cNvSpPr/>
+          <p:nvPr/>
+        </p:nvSpPr>
+        <p:spPr>
+          <a:xfrm>
+            <a:off x="6652260" y="2174520"/>
+            <a:ext cx="560000" cy="560000"/>
           </a:xfrm>
           <a:prstGeom prst="ellipse">
             <a:avLst/>
@@ -2908,7 +4015,7 @@
       </p:sp>
       <p:pic>
         <p:nvPicPr>
-          <p:cNvPr id="19" name="Image 4" descr="/home/claude/cryptosight_ppt/icons/eye_2D4A38.png"/>
+          <p:cNvPr id="121" name="Image" descr="eye icon"/>
           <p:cNvPicPr>
             <a:picLocks noChangeAspect="1"/>
           </p:cNvPicPr>
@@ -2922,8 +4029,8 @@
         </p:blipFill>
         <p:spPr>
           <a:xfrm>
-            <a:off x="6810268" y="2398288"/>
-            <a:ext cx="342351" cy="342351"/>
+            <a:off x="6787260" y="2309520"/>
+            <a:ext cx="290000" cy="290000"/>
           </a:xfrm>
           <a:prstGeom prst="rect">
             <a:avLst/>
@@ -2932,13 +4039,13 @@
       </p:pic>
       <p:sp>
         <p:nvSpPr>
-          <p:cNvPr id="20" name="Text 13"/>
-          <p:cNvSpPr/>
-          <p:nvPr/>
-        </p:nvSpPr>
-        <p:spPr>
-          <a:xfrm>
-            <a:off x="6652260" y="3044952"/>
+          <p:cNvPr id="122" name="Label"/>
+          <p:cNvSpPr/>
+          <p:nvPr/>
+        </p:nvSpPr>
+        <p:spPr>
+          <a:xfrm>
+            <a:off x="6652260" y="2844520"/>
             <a:ext cx="4366260" cy="292608"/>
           </a:xfrm>
           <a:prstGeom prst="rect">
@@ -2971,13 +4078,13 @@
       </p:sp>
       <p:sp>
         <p:nvSpPr>
-          <p:cNvPr id="21" name="Shape 14"/>
-          <p:cNvSpPr/>
-          <p:nvPr/>
-        </p:nvSpPr>
-        <p:spPr>
-          <a:xfrm>
-            <a:off x="6652260" y="3474720"/>
+          <p:cNvPr id="123" name="RowCircle"/>
+          <p:cNvSpPr/>
+          <p:nvPr/>
+        </p:nvSpPr>
+        <p:spPr>
+          <a:xfrm>
+            <a:off x="6652260" y="3247128"/>
             <a:ext cx="457200" cy="457200"/>
           </a:xfrm>
           <a:prstGeom prst="ellipse">
@@ -2998,7 +4105,7 @@
       </p:sp>
       <p:pic>
         <p:nvPicPr>
-          <p:cNvPr id="22" name="Image 5" descr="/home/claude/cryptosight_ppt/icons/check_2D4A38.png"/>
+          <p:cNvPr id="124" name="Image" descr="check icon"/>
           <p:cNvPicPr>
             <a:picLocks noChangeAspect="1"/>
           </p:cNvPicPr>
@@ -3012,7 +4119,7 @@
         </p:blipFill>
         <p:spPr>
           <a:xfrm>
-            <a:off x="6761988" y="3584448"/>
+            <a:off x="6761988" y="3356856"/>
             <a:ext cx="237744" cy="237744"/>
           </a:xfrm>
           <a:prstGeom prst="rect">
@@ -3022,13 +4129,13 @@
       </p:pic>
       <p:sp>
         <p:nvSpPr>
-          <p:cNvPr id="23" name="Text 15"/>
-          <p:cNvSpPr/>
-          <p:nvPr/>
-        </p:nvSpPr>
-        <p:spPr>
-          <a:xfrm>
-            <a:off x="7246620" y="3419856"/>
+          <p:cNvPr id="125" name="RowText"/>
+          <p:cNvSpPr/>
+          <p:nvPr/>
+        </p:nvSpPr>
+        <p:spPr>
+          <a:xfrm>
+            <a:off x="7246620" y="3192264"/>
             <a:ext cx="3771900" cy="594360"/>
           </a:xfrm>
           <a:prstGeom prst="rect">
@@ -3045,7 +4152,7 @@
               <a:buNone/>
             </a:pPr>
             <a:r>
-              <a:rPr lang="en-US" sz="1450" dirty="0">
+              <a:rPr lang="en-US" sz="1350" dirty="0">
                 <a:solidFill>
                   <a:srgbClr val="FFFFFF"/>
                 </a:solidFill>
@@ -3055,19 +4162,19 @@
               </a:rPr>
               <a:t>Watches the market 24/7</a:t>
             </a:r>
-            <a:endParaRPr lang="en-US" sz="1450" dirty="0"/>
-          </a:p>
-        </p:txBody>
-      </p:sp>
-      <p:sp>
-        <p:nvSpPr>
-          <p:cNvPr id="24" name="Shape 16"/>
-          <p:cNvSpPr/>
-          <p:nvPr/>
-        </p:nvSpPr>
-        <p:spPr>
-          <a:xfrm>
-            <a:off x="6652260" y="4251960"/>
+            <a:endParaRPr lang="en-US" sz="1350" dirty="0"/>
+          </a:p>
+        </p:txBody>
+      </p:sp>
+      <p:sp>
+        <p:nvSpPr>
+          <p:cNvPr id="126" name="RowCircle"/>
+          <p:cNvSpPr/>
+          <p:nvPr/>
+        </p:nvSpPr>
+        <p:spPr>
+          <a:xfrm>
+            <a:off x="6652260" y="3897128"/>
             <a:ext cx="457200" cy="457200"/>
           </a:xfrm>
           <a:prstGeom prst="ellipse">
@@ -3088,7 +4195,7 @@
       </p:sp>
       <p:pic>
         <p:nvPicPr>
-          <p:cNvPr id="25" name="Image 6" descr="/home/claude/cryptosight_ppt/icons/check_2D4A38.png"/>
+          <p:cNvPr id="127" name="Image" descr="check icon"/>
           <p:cNvPicPr>
             <a:picLocks noChangeAspect="1"/>
           </p:cNvPicPr>
@@ -3102,7 +4209,7 @@
         </p:blipFill>
         <p:spPr>
           <a:xfrm>
-            <a:off x="6761988" y="4361688"/>
+            <a:off x="6761988" y="4006856"/>
             <a:ext cx="237744" cy="237744"/>
           </a:xfrm>
           <a:prstGeom prst="rect">
@@ -3112,13 +4219,13 @@
       </p:pic>
       <p:sp>
         <p:nvSpPr>
-          <p:cNvPr id="26" name="Text 17"/>
-          <p:cNvSpPr/>
-          <p:nvPr/>
-        </p:nvSpPr>
-        <p:spPr>
-          <a:xfrm>
-            <a:off x="7246620" y="4197096"/>
+          <p:cNvPr id="128" name="RowText"/>
+          <p:cNvSpPr/>
+          <p:nvPr/>
+        </p:nvSpPr>
+        <p:spPr>
+          <a:xfrm>
+            <a:off x="7246620" y="3842264"/>
             <a:ext cx="3771900" cy="594360"/>
           </a:xfrm>
           <a:prstGeom prst="rect">
@@ -3135,7 +4242,7 @@
               <a:buNone/>
             </a:pPr>
             <a:r>
-              <a:rPr lang="en-US" sz="1450" dirty="0">
+              <a:rPr lang="en-US" sz="1350" dirty="0">
                 <a:solidFill>
                   <a:srgbClr val="FFFFFF"/>
                 </a:solidFill>
@@ -3145,19 +4252,19 @@
               </a:rPr>
               <a:t>Auto-checks every signal &amp; indicator</a:t>
             </a:r>
-            <a:endParaRPr lang="en-US" sz="1450" dirty="0"/>
-          </a:p>
-        </p:txBody>
-      </p:sp>
-      <p:sp>
-        <p:nvSpPr>
-          <p:cNvPr id="27" name="Shape 18"/>
-          <p:cNvSpPr/>
-          <p:nvPr/>
-        </p:nvSpPr>
-        <p:spPr>
-          <a:xfrm>
-            <a:off x="6652260" y="5029200"/>
+            <a:endParaRPr lang="en-US" sz="1350" dirty="0"/>
+          </a:p>
+        </p:txBody>
+      </p:sp>
+      <p:sp>
+        <p:nvSpPr>
+          <p:cNvPr id="129" name="RowCircle"/>
+          <p:cNvSpPr/>
+          <p:nvPr/>
+        </p:nvSpPr>
+        <p:spPr>
+          <a:xfrm>
+            <a:off x="6652260" y="4547128"/>
             <a:ext cx="457200" cy="457200"/>
           </a:xfrm>
           <a:prstGeom prst="ellipse">
@@ -3178,7 +4285,7 @@
       </p:sp>
       <p:pic>
         <p:nvPicPr>
-          <p:cNvPr id="28" name="Image 7" descr="/home/claude/cryptosight_ppt/icons/check_2D4A38.png"/>
+          <p:cNvPr id="130" name="Image" descr="check icon"/>
           <p:cNvPicPr>
             <a:picLocks noChangeAspect="1"/>
           </p:cNvPicPr>
@@ -3192,7 +4299,7 @@
         </p:blipFill>
         <p:spPr>
           <a:xfrm>
-            <a:off x="6761988" y="5138928"/>
+            <a:off x="6761988" y="4656856"/>
             <a:ext cx="237744" cy="237744"/>
           </a:xfrm>
           <a:prstGeom prst="rect">
@@ -3202,13 +4309,13 @@
       </p:pic>
       <p:sp>
         <p:nvSpPr>
-          <p:cNvPr id="29" name="Text 19"/>
-          <p:cNvSpPr/>
-          <p:nvPr/>
-        </p:nvSpPr>
-        <p:spPr>
-          <a:xfrm>
-            <a:off x="7246620" y="4974336"/>
+          <p:cNvPr id="131" name="RowText"/>
+          <p:cNvSpPr/>
+          <p:nvPr/>
+        </p:nvSpPr>
+        <p:spPr>
+          <a:xfrm>
+            <a:off x="7246620" y="4492264"/>
             <a:ext cx="3771900" cy="594360"/>
           </a:xfrm>
           <a:prstGeom prst="rect">
@@ -3225,7 +4332,7 @@
               <a:buNone/>
             </a:pPr>
             <a:r>
-              <a:rPr lang="en-US" sz="1450" dirty="0">
+              <a:rPr lang="en-US" sz="1350" dirty="0">
                 <a:solidFill>
                   <a:srgbClr val="FFFFFF"/>
                 </a:solidFill>
@@ -3235,7 +4342,187 @@
               </a:rPr>
               <a:t>Tests, executes, reports - one dashboard</a:t>
             </a:r>
-            <a:endParaRPr lang="en-US" sz="1450" dirty="0"/>
+            <a:endParaRPr lang="en-US" sz="1350" dirty="0"/>
+          </a:p>
+        </p:txBody>
+      </p:sp>
+      <p:sp>
+        <p:nvSpPr>
+          <p:cNvPr id="132" name="RowCircle"/>
+          <p:cNvSpPr/>
+          <p:nvPr/>
+        </p:nvSpPr>
+        <p:spPr>
+          <a:xfrm>
+            <a:off x="6652260" y="5197128"/>
+            <a:ext cx="457200" cy="457200"/>
+          </a:xfrm>
+          <a:prstGeom prst="ellipse">
+            <a:avLst/>
+          </a:prstGeom>
+          <a:solidFill>
+            <a:srgbClr val="7DAD8C"/>
+          </a:solidFill>
+          <a:ln/>
+          <a:effectLst>
+            <a:outerShdw blurRad="127000" dist="38100" dir="5400000" algn="bl" rotWithShape="0">
+              <a:srgbClr val="1B2A21">
+                <a:alpha val="16000"/>
+              </a:srgbClr>
+            </a:outerShdw>
+          </a:effectLst>
+        </p:spPr>
+      </p:sp>
+      <p:pic>
+        <p:nvPicPr>
+          <p:cNvPr id="133" name="Image" descr="check icon"/>
+          <p:cNvPicPr>
+            <a:picLocks noChangeAspect="1"/>
+          </p:cNvPicPr>
+          <p:nvPr/>
+        </p:nvPicPr>
+        <p:blipFill>
+          <a:blip r:embed="rId7"/>
+          <a:stretch>
+            <a:fillRect/>
+          </a:stretch>
+        </p:blipFill>
+        <p:spPr>
+          <a:xfrm>
+            <a:off x="6761988" y="5306856"/>
+            <a:ext cx="237744" cy="237744"/>
+          </a:xfrm>
+          <a:prstGeom prst="rect">
+            <a:avLst/>
+          </a:prstGeom>
+        </p:spPr>
+      </p:pic>
+      <p:sp>
+        <p:nvSpPr>
+          <p:cNvPr id="134" name="RowText"/>
+          <p:cNvSpPr/>
+          <p:nvPr/>
+        </p:nvSpPr>
+        <p:spPr>
+          <a:xfrm>
+            <a:off x="7246620" y="5142264"/>
+            <a:ext cx="3771900" cy="594360"/>
+          </a:xfrm>
+          <a:prstGeom prst="rect">
+            <a:avLst/>
+          </a:prstGeom>
+          <a:noFill/>
+          <a:ln/>
+        </p:spPr>
+        <p:txBody>
+          <a:bodyPr wrap="square" lIns="0" tIns="0" rIns="0" bIns="0" rtlCol="0" anchor="ctr"/>
+          <a:lstStyle/>
+          <a:p>
+            <a:pPr marL="0" indent="0">
+              <a:buNone/>
+            </a:pPr>
+            <a:r>
+              <a:rPr lang="en-US" sz="1350" dirty="0">
+                <a:solidFill>
+                  <a:srgbClr val="FFFFFF"/>
+                </a:solidFill>
+                <a:latin typeface="Calibri" pitchFamily="34" charset="0"/>
+                <a:ea typeface="Calibri" pitchFamily="34" charset="-122"/>
+                <a:cs typeface="Calibri" pitchFamily="34" charset="-120"/>
+              </a:rPr>
+              <a:t>Every strategy backtested on historical data first</a:t>
+            </a:r>
+            <a:endParaRPr lang="en-US" sz="1350" dirty="0"/>
+          </a:p>
+        </p:txBody>
+      </p:sp>
+      <p:sp>
+        <p:nvSpPr>
+          <p:cNvPr id="135" name="RowCircle"/>
+          <p:cNvSpPr/>
+          <p:nvPr/>
+        </p:nvSpPr>
+        <p:spPr>
+          <a:xfrm>
+            <a:off x="6652260" y="5847128"/>
+            <a:ext cx="457200" cy="457200"/>
+          </a:xfrm>
+          <a:prstGeom prst="ellipse">
+            <a:avLst/>
+          </a:prstGeom>
+          <a:solidFill>
+            <a:srgbClr val="7DAD8C"/>
+          </a:solidFill>
+          <a:ln/>
+          <a:effectLst>
+            <a:outerShdw blurRad="127000" dist="38100" dir="5400000" algn="bl" rotWithShape="0">
+              <a:srgbClr val="1B2A21">
+                <a:alpha val="16000"/>
+              </a:srgbClr>
+            </a:outerShdw>
+          </a:effectLst>
+        </p:spPr>
+      </p:sp>
+      <p:pic>
+        <p:nvPicPr>
+          <p:cNvPr id="136" name="Image" descr="check icon"/>
+          <p:cNvPicPr>
+            <a:picLocks noChangeAspect="1"/>
+          </p:cNvPicPr>
+          <p:nvPr/>
+        </p:nvPicPr>
+        <p:blipFill>
+          <a:blip r:embed="rId7"/>
+          <a:stretch>
+            <a:fillRect/>
+          </a:stretch>
+        </p:blipFill>
+        <p:spPr>
+          <a:xfrm>
+            <a:off x="6761988" y="5956856"/>
+            <a:ext cx="237744" cy="237744"/>
+          </a:xfrm>
+          <a:prstGeom prst="rect">
+            <a:avLst/>
+          </a:prstGeom>
+        </p:spPr>
+      </p:pic>
+      <p:sp>
+        <p:nvSpPr>
+          <p:cNvPr id="137" name="RowText"/>
+          <p:cNvSpPr/>
+          <p:nvPr/>
+        </p:nvSpPr>
+        <p:spPr>
+          <a:xfrm>
+            <a:off x="7246620" y="5792264"/>
+            <a:ext cx="3771900" cy="594360"/>
+          </a:xfrm>
+          <a:prstGeom prst="rect">
+            <a:avLst/>
+          </a:prstGeom>
+          <a:noFill/>
+          <a:ln/>
+        </p:spPr>
+        <p:txBody>
+          <a:bodyPr wrap="square" lIns="0" tIns="0" rIns="0" bIns="0" rtlCol="0" anchor="ctr"/>
+          <a:lstStyle/>
+          <a:p>
+            <a:pPr marL="0" indent="0">
+              <a:buNone/>
+            </a:pPr>
+            <a:r>
+              <a:rPr lang="en-US" sz="1350" dirty="0">
+                <a:solidFill>
+                  <a:srgbClr val="FFFFFF"/>
+                </a:solidFill>
+                <a:latin typeface="Calibri" pitchFamily="34" charset="0"/>
+                <a:ea typeface="Calibri" pitchFamily="34" charset="-122"/>
+                <a:cs typeface="Calibri" pitchFamily="34" charset="-120"/>
+              </a:rPr>
+              <a:t>Backtests across multiple assets to find what works</a:t>
+            </a:r>
+            <a:endParaRPr lang="en-US" sz="1350" dirty="0"/>
           </a:p>
         </p:txBody>
       </p:sp>
@@ -5554,7 +6841,7 @@
       </p:sp>
       <p:pic>
         <p:nvPicPr>
-          <p:cNvPr id="13" name="Image 1" descr="/home/claude/cryptosight_ppt/icons/chartline_FFFFFF.png"/>
+          <p:cNvPr id="13" name="Image 1" descr="/home/claude/cryptosight_ppt/icons/broadcast_FFFFFF.png"/>
           <p:cNvPicPr>
             <a:picLocks noChangeAspect="1"/>
           </p:cNvPicPr>
@@ -5609,7 +6896,7 @@
                 <a:ea typeface="Calibri" pitchFamily="34" charset="-122"/>
                 <a:cs typeface="Calibri" pitchFamily="34" charset="-120"/>
               </a:rPr>
-              <a:t>AI ENHANCEMENT</a:t>
+              <a:t>ENHANCEMENT</a:t>
             </a:r>
             <a:endParaRPr lang="en-US" sz="950" dirty="0"/>
           </a:p>
@@ -5648,7 +6935,7 @@
                 <a:ea typeface="Calibri" pitchFamily="34" charset="-122"/>
                 <a:cs typeface="Calibri" pitchFamily="34" charset="-120"/>
               </a:rPr>
-              <a:t>AI Market Filter</a:t>
+              <a:t>Trade Alerts</a:t>
             </a:r>
             <a:endParaRPr lang="en-US" sz="1600" dirty="0"/>
           </a:p>
@@ -5690,7 +6977,7 @@
                 <a:ea typeface="Calibri" pitchFamily="34" charset="-122"/>
                 <a:cs typeface="Calibri" pitchFamily="34" charset="-120"/>
               </a:rPr>
-              <a:t>Spots bad markets and pauses trading</a:t>
+              <a:t>Instant Telegram &amp; email trade alerts</a:t>
             </a:r>
             <a:endParaRPr lang="en-US" sz="1250" dirty="0"/>
           </a:p>
@@ -5954,7 +7241,7 @@
       </p:sp>
       <p:pic>
         <p:nvPicPr>
-          <p:cNvPr id="25" name="Image 3" descr="/home/claude/cryptosight_ppt/icons/warning_FFFFFF.png"/>
+          <p:cNvPr id="25" name="Image 3" descr="/home/claude/cryptosight_ppt/icons/server_FFFFFF.png"/>
           <p:cNvPicPr>
             <a:picLocks noChangeAspect="1"/>
           </p:cNvPicPr>
@@ -6009,7 +7296,7 @@
                 <a:ea typeface="Calibri" pitchFamily="34" charset="-122"/>
                 <a:cs typeface="Calibri" pitchFamily="34" charset="-120"/>
               </a:rPr>
-              <a:t>AI ENHANCEMENT</a:t>
+              <a:t>ENHANCEMENT</a:t>
             </a:r>
             <a:endParaRPr lang="en-US" sz="950" dirty="0"/>
           </a:p>
@@ -6048,7 +7335,7 @@
                 <a:ea typeface="Calibri" pitchFamily="34" charset="-122"/>
                 <a:cs typeface="Calibri" pitchFamily="34" charset="-120"/>
               </a:rPr>
-              <a:t>Anomaly Detector</a:t>
+              <a:t>Multi-Exchange Support</a:t>
             </a:r>
             <a:endParaRPr lang="en-US" sz="1600" dirty="0"/>
           </a:p>
@@ -6090,7 +7377,7 @@
                 <a:ea typeface="Calibri" pitchFamily="34" charset="-122"/>
                 <a:cs typeface="Calibri" pitchFamily="34" charset="-120"/>
               </a:rPr>
-              <a:t>Warns of fake price moves early</a:t>
+              <a:t>Connect and trade across more exchanges</a:t>
             </a:r>
             <a:endParaRPr lang="en-US" sz="1250" dirty="0"/>
           </a:p>
@@ -6455,6 +7742,440 @@
               <a:t>Afnan Shoukat</a:t>
             </a:r>
             <a:endParaRPr lang="en-US" sz="1200" dirty="0"/>
+          </a:p>
+        </p:txBody>
+      </p:sp>
+      <p:sp>
+        <p:nvSpPr>
+          <p:cNvPr id="200" name="Candle Wick 0"/>
+          <p:cNvSpPr/>
+          <p:nvPr/>
+        </p:nvSpPr>
+        <p:spPr>
+          <a:xfrm>
+            <a:off x="8954786" y="1064000"/>
+            <a:ext cx="26142" cy="591999"/>
+          </a:xfrm>
+          <a:prstGeom prst="rect">
+            <a:avLst/>
+          </a:prstGeom>
+          <a:solidFill>
+            <a:srgbClr val="E38B8B">
+              <a:alpha val="70000"/>
+            </a:srgbClr>
+          </a:solidFill>
+          <a:ln>
+            <a:noFill/>
+          </a:ln>
+        </p:spPr>
+        <p:txBody>
+          <a:bodyPr/>
+          <a:lstStyle/>
+          <a:p>
+            <a:endParaRPr lang="en-US"/>
+          </a:p>
+        </p:txBody>
+      </p:sp>
+      <p:sp>
+        <p:nvSpPr>
+          <p:cNvPr id="201" name="Candle Body 0"/>
+          <p:cNvSpPr/>
+          <p:nvPr/>
+        </p:nvSpPr>
+        <p:spPr>
+          <a:xfrm>
+            <a:off x="8876358" y="1167600"/>
+            <a:ext cx="182999" cy="414400"/>
+          </a:xfrm>
+          <a:prstGeom prst="rect">
+            <a:avLst/>
+          </a:prstGeom>
+          <a:solidFill>
+            <a:srgbClr val="E38B8B">
+              <a:alpha val="70000"/>
+            </a:srgbClr>
+          </a:solidFill>
+          <a:ln>
+            <a:noFill/>
+          </a:ln>
+        </p:spPr>
+        <p:txBody>
+          <a:bodyPr/>
+          <a:lstStyle/>
+          <a:p>
+            <a:endParaRPr lang="en-US"/>
+          </a:p>
+        </p:txBody>
+      </p:sp>
+      <p:sp>
+        <p:nvSpPr>
+          <p:cNvPr id="202" name="Candle Wick 1"/>
+          <p:cNvSpPr/>
+          <p:nvPr/>
+        </p:nvSpPr>
+        <p:spPr>
+          <a:xfrm>
+            <a:off x="9390500" y="842000"/>
+            <a:ext cx="26142" cy="562400"/>
+          </a:xfrm>
+          <a:prstGeom prst="rect">
+            <a:avLst/>
+          </a:prstGeom>
+          <a:solidFill>
+            <a:srgbClr val="7DAD8C">
+              <a:alpha val="70000"/>
+            </a:srgbClr>
+          </a:solidFill>
+          <a:ln>
+            <a:noFill/>
+          </a:ln>
+        </p:spPr>
+        <p:txBody>
+          <a:bodyPr/>
+          <a:lstStyle/>
+          <a:p>
+            <a:endParaRPr lang="en-US"/>
+          </a:p>
+        </p:txBody>
+      </p:sp>
+      <p:sp>
+        <p:nvSpPr>
+          <p:cNvPr id="203" name="Candle Body 1"/>
+          <p:cNvSpPr/>
+          <p:nvPr/>
+        </p:nvSpPr>
+        <p:spPr>
+          <a:xfrm>
+            <a:off x="9312072" y="960400"/>
+            <a:ext cx="182999" cy="325599"/>
+          </a:xfrm>
+          <a:prstGeom prst="rect">
+            <a:avLst/>
+          </a:prstGeom>
+          <a:solidFill>
+            <a:srgbClr val="7DAD8C">
+              <a:alpha val="70000"/>
+            </a:srgbClr>
+          </a:solidFill>
+          <a:ln>
+            <a:noFill/>
+          </a:ln>
+        </p:spPr>
+        <p:txBody>
+          <a:bodyPr/>
+          <a:lstStyle/>
+          <a:p>
+            <a:endParaRPr lang="en-US"/>
+          </a:p>
+        </p:txBody>
+      </p:sp>
+      <p:sp>
+        <p:nvSpPr>
+          <p:cNvPr id="204" name="Candle Wick 2"/>
+          <p:cNvSpPr/>
+          <p:nvPr/>
+        </p:nvSpPr>
+        <p:spPr>
+          <a:xfrm>
+            <a:off x="9826214" y="990000"/>
+            <a:ext cx="26142" cy="473599"/>
+          </a:xfrm>
+          <a:prstGeom prst="rect">
+            <a:avLst/>
+          </a:prstGeom>
+          <a:solidFill>
+            <a:srgbClr val="E38B8B">
+              <a:alpha val="70000"/>
+            </a:srgbClr>
+          </a:solidFill>
+          <a:ln>
+            <a:noFill/>
+          </a:ln>
+        </p:spPr>
+        <p:txBody>
+          <a:bodyPr/>
+          <a:lstStyle/>
+          <a:p>
+            <a:endParaRPr lang="en-US"/>
+          </a:p>
+        </p:txBody>
+      </p:sp>
+      <p:sp>
+        <p:nvSpPr>
+          <p:cNvPr id="205" name="Candle Body 2"/>
+          <p:cNvSpPr/>
+          <p:nvPr/>
+        </p:nvSpPr>
+        <p:spPr>
+          <a:xfrm>
+            <a:off x="9747786" y="1064000"/>
+            <a:ext cx="182999" cy="295999"/>
+          </a:xfrm>
+          <a:prstGeom prst="rect">
+            <a:avLst/>
+          </a:prstGeom>
+          <a:solidFill>
+            <a:srgbClr val="E38B8B">
+              <a:alpha val="70000"/>
+            </a:srgbClr>
+          </a:solidFill>
+          <a:ln>
+            <a:noFill/>
+          </a:ln>
+        </p:spPr>
+        <p:txBody>
+          <a:bodyPr/>
+          <a:lstStyle/>
+          <a:p>
+            <a:endParaRPr lang="en-US"/>
+          </a:p>
+        </p:txBody>
+      </p:sp>
+      <p:sp>
+        <p:nvSpPr>
+          <p:cNvPr id="206" name="Candle Wick 3"/>
+          <p:cNvSpPr/>
+          <p:nvPr/>
+        </p:nvSpPr>
+        <p:spPr>
+          <a:xfrm>
+            <a:off x="10261928" y="575600"/>
+            <a:ext cx="26142" cy="592000"/>
+          </a:xfrm>
+          <a:prstGeom prst="rect">
+            <a:avLst/>
+          </a:prstGeom>
+          <a:solidFill>
+            <a:srgbClr val="7DAD8C">
+              <a:alpha val="70000"/>
+            </a:srgbClr>
+          </a:solidFill>
+          <a:ln>
+            <a:noFill/>
+          </a:ln>
+        </p:spPr>
+        <p:txBody>
+          <a:bodyPr/>
+          <a:lstStyle/>
+          <a:p>
+            <a:endParaRPr lang="en-US"/>
+          </a:p>
+        </p:txBody>
+      </p:sp>
+      <p:sp>
+        <p:nvSpPr>
+          <p:cNvPr id="207" name="Candle Body 3"/>
+          <p:cNvSpPr/>
+          <p:nvPr/>
+        </p:nvSpPr>
+        <p:spPr>
+          <a:xfrm>
+            <a:off x="10183500" y="694000"/>
+            <a:ext cx="182999" cy="370000"/>
+          </a:xfrm>
+          <a:prstGeom prst="rect">
+            <a:avLst/>
+          </a:prstGeom>
+          <a:solidFill>
+            <a:srgbClr val="7DAD8C">
+              <a:alpha val="70000"/>
+            </a:srgbClr>
+          </a:solidFill>
+          <a:ln>
+            <a:noFill/>
+          </a:ln>
+        </p:spPr>
+        <p:txBody>
+          <a:bodyPr/>
+          <a:lstStyle/>
+          <a:p>
+            <a:endParaRPr lang="en-US"/>
+          </a:p>
+        </p:txBody>
+      </p:sp>
+      <p:sp>
+        <p:nvSpPr>
+          <p:cNvPr id="208" name="Candle Wick 4"/>
+          <p:cNvSpPr/>
+          <p:nvPr/>
+        </p:nvSpPr>
+        <p:spPr>
+          <a:xfrm>
+            <a:off x="10697642" y="723600"/>
+            <a:ext cx="26142" cy="488400"/>
+          </a:xfrm>
+          <a:prstGeom prst="rect">
+            <a:avLst/>
+          </a:prstGeom>
+          <a:solidFill>
+            <a:srgbClr val="E38B8B">
+              <a:alpha val="70000"/>
+            </a:srgbClr>
+          </a:solidFill>
+          <a:ln>
+            <a:noFill/>
+          </a:ln>
+        </p:spPr>
+        <p:txBody>
+          <a:bodyPr/>
+          <a:lstStyle/>
+          <a:p>
+            <a:endParaRPr lang="en-US"/>
+          </a:p>
+        </p:txBody>
+      </p:sp>
+      <p:sp>
+        <p:nvSpPr>
+          <p:cNvPr id="209" name="Candle Body 4"/>
+          <p:cNvSpPr/>
+          <p:nvPr/>
+        </p:nvSpPr>
+        <p:spPr>
+          <a:xfrm>
+            <a:off x="10619214" y="812400"/>
+            <a:ext cx="182999" cy="295999"/>
+          </a:xfrm>
+          <a:prstGeom prst="rect">
+            <a:avLst/>
+          </a:prstGeom>
+          <a:solidFill>
+            <a:srgbClr val="E38B8B">
+              <a:alpha val="70000"/>
+            </a:srgbClr>
+          </a:solidFill>
+          <a:ln>
+            <a:noFill/>
+          </a:ln>
+        </p:spPr>
+        <p:txBody>
+          <a:bodyPr/>
+          <a:lstStyle/>
+          <a:p>
+            <a:endParaRPr lang="en-US"/>
+          </a:p>
+        </p:txBody>
+      </p:sp>
+      <p:sp>
+        <p:nvSpPr>
+          <p:cNvPr id="210" name="Candle Wick 5"/>
+          <p:cNvSpPr/>
+          <p:nvPr/>
+        </p:nvSpPr>
+        <p:spPr>
+          <a:xfrm>
+            <a:off x="11133356" y="368400"/>
+            <a:ext cx="26142" cy="562400"/>
+          </a:xfrm>
+          <a:prstGeom prst="rect">
+            <a:avLst/>
+          </a:prstGeom>
+          <a:solidFill>
+            <a:srgbClr val="7DAD8C">
+              <a:alpha val="70000"/>
+            </a:srgbClr>
+          </a:solidFill>
+          <a:ln>
+            <a:noFill/>
+          </a:ln>
+        </p:spPr>
+        <p:txBody>
+          <a:bodyPr/>
+          <a:lstStyle/>
+          <a:p>
+            <a:endParaRPr lang="en-US"/>
+          </a:p>
+        </p:txBody>
+      </p:sp>
+      <p:sp>
+        <p:nvSpPr>
+          <p:cNvPr id="211" name="Candle Body 5"/>
+          <p:cNvSpPr/>
+          <p:nvPr/>
+        </p:nvSpPr>
+        <p:spPr>
+          <a:xfrm>
+            <a:off x="11054928" y="457200"/>
+            <a:ext cx="182999" cy="384800"/>
+          </a:xfrm>
+          <a:prstGeom prst="rect">
+            <a:avLst/>
+          </a:prstGeom>
+          <a:solidFill>
+            <a:srgbClr val="7DAD8C">
+              <a:alpha val="70000"/>
+            </a:srgbClr>
+          </a:solidFill>
+          <a:ln>
+            <a:noFill/>
+          </a:ln>
+        </p:spPr>
+        <p:txBody>
+          <a:bodyPr/>
+          <a:lstStyle/>
+          <a:p>
+            <a:endParaRPr lang="en-US"/>
+          </a:p>
+        </p:txBody>
+      </p:sp>
+      <p:sp>
+        <p:nvSpPr>
+          <p:cNvPr id="212" name="Candle Wick 6"/>
+          <p:cNvSpPr/>
+          <p:nvPr/>
+        </p:nvSpPr>
+        <p:spPr>
+          <a:xfrm>
+            <a:off x="11569070" y="250000"/>
+            <a:ext cx="26142" cy="503200"/>
+          </a:xfrm>
+          <a:prstGeom prst="rect">
+            <a:avLst/>
+          </a:prstGeom>
+          <a:solidFill>
+            <a:srgbClr val="7DAD8C">
+              <a:alpha val="70000"/>
+            </a:srgbClr>
+          </a:solidFill>
+          <a:ln>
+            <a:noFill/>
+          </a:ln>
+        </p:spPr>
+        <p:txBody>
+          <a:bodyPr/>
+          <a:lstStyle/>
+          <a:p>
+            <a:endParaRPr lang="en-US"/>
+          </a:p>
+        </p:txBody>
+      </p:sp>
+      <p:sp>
+        <p:nvSpPr>
+          <p:cNvPr id="213" name="Candle Body 6"/>
+          <p:cNvSpPr/>
+          <p:nvPr/>
+        </p:nvSpPr>
+        <p:spPr>
+          <a:xfrm>
+            <a:off x="11490642" y="324000"/>
+            <a:ext cx="182999" cy="340400"/>
+          </a:xfrm>
+          <a:prstGeom prst="rect">
+            <a:avLst/>
+          </a:prstGeom>
+          <a:solidFill>
+            <a:srgbClr val="7DAD8C">
+              <a:alpha val="70000"/>
+            </a:srgbClr>
+          </a:solidFill>
+          <a:ln>
+            <a:noFill/>
+          </a:ln>
+        </p:spPr>
+        <p:txBody>
+          <a:bodyPr/>
+          <a:lstStyle/>
+          <a:p>
+            <a:endParaRPr lang="en-US"/>
           </a:p>
         </p:txBody>
       </p:sp>

</xml_diff>